<commit_message>
change ip routing and so
</commit_message>
<xml_diff>
--- a/1.4 Direct Links/1.4 Direct Links.pptx
+++ b/1.4 Direct Links/1.4 Direct Links.pptx
@@ -189,7 +189,7 @@
           <a:noFill/>
           <a:extLst>
             <a:ext uri="{909E8E84-426E-40dd-AFC4-6F175D3DCCD1}">
-              <a14:hiddenFill xmlns:a14="http://schemas.microsoft.com/office/drawing/2010/main" xmlns="">
+              <a14:hiddenFill xmlns="" xmlns:a14="http://schemas.microsoft.com/office/drawing/2010/main">
                 <a:solidFill>
                   <a:srgbClr val="FFFFFF"/>
                 </a:solidFill>
@@ -248,7 +248,7 @@
             </a:ln>
             <a:extLst>
               <a:ext uri="{91240B29-F687-4f45-9708-019B960494DF}">
-                <a14:hiddenLine xmlns:a14="http://schemas.microsoft.com/office/drawing/2010/main" xmlns="" w="9525">
+                <a14:hiddenLine xmlns="" xmlns:a14="http://schemas.microsoft.com/office/drawing/2010/main" w="9525">
                   <a:solidFill>
                     <a:srgbClr val="000000"/>
                   </a:solidFill>
@@ -338,7 +338,7 @@
             </a:ln>
             <a:extLst>
               <a:ext uri="{91240B29-F687-4f45-9708-019B960494DF}">
-                <a14:hiddenLine xmlns:a14="http://schemas.microsoft.com/office/drawing/2010/main" xmlns="" w="9525">
+                <a14:hiddenLine xmlns="" xmlns:a14="http://schemas.microsoft.com/office/drawing/2010/main" w="9525">
                   <a:solidFill>
                     <a:srgbClr val="000000"/>
                   </a:solidFill>
@@ -428,7 +428,7 @@
             </a:ln>
             <a:extLst>
               <a:ext uri="{91240B29-F687-4f45-9708-019B960494DF}">
-                <a14:hiddenLine xmlns:a14="http://schemas.microsoft.com/office/drawing/2010/main" xmlns="" w="9525">
+                <a14:hiddenLine xmlns="" xmlns:a14="http://schemas.microsoft.com/office/drawing/2010/main" w="9525">
                   <a:solidFill>
                     <a:srgbClr val="000000"/>
                   </a:solidFill>
@@ -462,7 +462,7 @@
             </a:ln>
             <a:extLst>
               <a:ext uri="{91240B29-F687-4f45-9708-019B960494DF}">
-                <a14:hiddenLine xmlns:a14="http://schemas.microsoft.com/office/drawing/2010/main" xmlns="" w="9525">
+                <a14:hiddenLine xmlns="" xmlns:a14="http://schemas.microsoft.com/office/drawing/2010/main" w="9525">
                   <a:solidFill>
                     <a:srgbClr val="000000"/>
                   </a:solidFill>
@@ -552,7 +552,7 @@
             </a:ln>
             <a:extLst>
               <a:ext uri="{91240B29-F687-4f45-9708-019B960494DF}">
-                <a14:hiddenLine xmlns:a14="http://schemas.microsoft.com/office/drawing/2010/main" xmlns="" w="9525">
+                <a14:hiddenLine xmlns="" xmlns:a14="http://schemas.microsoft.com/office/drawing/2010/main" w="9525">
                   <a:solidFill>
                     <a:srgbClr val="000000"/>
                   </a:solidFill>
@@ -614,7 +614,7 @@
             </a:ln>
             <a:extLst>
               <a:ext uri="{91240B29-F687-4f45-9708-019B960494DF}">
-                <a14:hiddenLine xmlns:a14="http://schemas.microsoft.com/office/drawing/2010/main" xmlns="" w="9525">
+                <a14:hiddenLine xmlns="" xmlns:a14="http://schemas.microsoft.com/office/drawing/2010/main" w="9525">
                   <a:solidFill>
                     <a:srgbClr val="000000"/>
                   </a:solidFill>
@@ -676,7 +676,7 @@
             </a:ln>
             <a:extLst>
               <a:ext uri="{91240B29-F687-4f45-9708-019B960494DF}">
-                <a14:hiddenLine xmlns:a14="http://schemas.microsoft.com/office/drawing/2010/main" xmlns="" w="9525">
+                <a14:hiddenLine xmlns="" xmlns:a14="http://schemas.microsoft.com/office/drawing/2010/main" w="9525">
                   <a:solidFill>
                     <a:srgbClr val="000000"/>
                   </a:solidFill>
@@ -766,7 +766,7 @@
             </a:ln>
             <a:extLst>
               <a:ext uri="{91240B29-F687-4f45-9708-019B960494DF}">
-                <a14:hiddenLine xmlns:a14="http://schemas.microsoft.com/office/drawing/2010/main" xmlns="" w="9525">
+                <a14:hiddenLine xmlns="" xmlns:a14="http://schemas.microsoft.com/office/drawing/2010/main" w="9525">
                   <a:solidFill>
                     <a:srgbClr val="000000"/>
                   </a:solidFill>
@@ -828,7 +828,7 @@
             </a:ln>
             <a:extLst>
               <a:ext uri="{91240B29-F687-4f45-9708-019B960494DF}">
-                <a14:hiddenLine xmlns:a14="http://schemas.microsoft.com/office/drawing/2010/main" xmlns="" w="9525">
+                <a14:hiddenLine xmlns="" xmlns:a14="http://schemas.microsoft.com/office/drawing/2010/main" w="9525">
                   <a:solidFill>
                     <a:srgbClr val="000000"/>
                   </a:solidFill>
@@ -890,7 +890,7 @@
             </a:ln>
             <a:extLst>
               <a:ext uri="{91240B29-F687-4f45-9708-019B960494DF}">
-                <a14:hiddenLine xmlns:a14="http://schemas.microsoft.com/office/drawing/2010/main" xmlns="" w="9525">
+                <a14:hiddenLine xmlns="" xmlns:a14="http://schemas.microsoft.com/office/drawing/2010/main" w="9525">
                   <a:solidFill>
                     <a:srgbClr val="000000"/>
                   </a:solidFill>
@@ -980,7 +980,7 @@
             </a:ln>
             <a:extLst>
               <a:ext uri="{91240B29-F687-4f45-9708-019B960494DF}">
-                <a14:hiddenLine xmlns:a14="http://schemas.microsoft.com/office/drawing/2010/main" xmlns="" w="9525">
+                <a14:hiddenLine xmlns="" xmlns:a14="http://schemas.microsoft.com/office/drawing/2010/main" w="9525">
                   <a:solidFill>
                     <a:srgbClr val="000000"/>
                   </a:solidFill>
@@ -1070,7 +1070,7 @@
             </a:ln>
             <a:extLst>
               <a:ext uri="{91240B29-F687-4f45-9708-019B960494DF}">
-                <a14:hiddenLine xmlns:a14="http://schemas.microsoft.com/office/drawing/2010/main" xmlns="" w="9525">
+                <a14:hiddenLine xmlns="" xmlns:a14="http://schemas.microsoft.com/office/drawing/2010/main" w="9525">
                   <a:solidFill>
                     <a:srgbClr val="000000"/>
                   </a:solidFill>
@@ -1132,7 +1132,7 @@
             </a:ln>
             <a:extLst>
               <a:ext uri="{91240B29-F687-4f45-9708-019B960494DF}">
-                <a14:hiddenLine xmlns:a14="http://schemas.microsoft.com/office/drawing/2010/main" xmlns="" w="9525">
+                <a14:hiddenLine xmlns="" xmlns:a14="http://schemas.microsoft.com/office/drawing/2010/main" w="9525">
                   <a:solidFill>
                     <a:srgbClr val="000000"/>
                   </a:solidFill>
@@ -1242,7 +1242,7 @@
             </a:ln>
             <a:extLst>
               <a:ext uri="{91240B29-F687-4f45-9708-019B960494DF}">
-                <a14:hiddenLine xmlns:a14="http://schemas.microsoft.com/office/drawing/2010/main" xmlns="" w="9525">
+                <a14:hiddenLine xmlns="" xmlns:a14="http://schemas.microsoft.com/office/drawing/2010/main" w="9525">
                   <a:solidFill>
                     <a:srgbClr val="000000"/>
                   </a:solidFill>
@@ -1304,7 +1304,7 @@
             </a:ln>
             <a:extLst>
               <a:ext uri="{91240B29-F687-4f45-9708-019B960494DF}">
-                <a14:hiddenLine xmlns:a14="http://schemas.microsoft.com/office/drawing/2010/main" xmlns="" w="9525">
+                <a14:hiddenLine xmlns="" xmlns:a14="http://schemas.microsoft.com/office/drawing/2010/main" w="9525">
                   <a:solidFill>
                     <a:srgbClr val="000000"/>
                   </a:solidFill>
@@ -1394,7 +1394,7 @@
             </a:ln>
             <a:extLst>
               <a:ext uri="{91240B29-F687-4f45-9708-019B960494DF}">
-                <a14:hiddenLine xmlns:a14="http://schemas.microsoft.com/office/drawing/2010/main" xmlns="" w="9525">
+                <a14:hiddenLine xmlns="" xmlns:a14="http://schemas.microsoft.com/office/drawing/2010/main" w="9525">
                   <a:solidFill>
                     <a:srgbClr val="000000"/>
                   </a:solidFill>
@@ -1484,7 +1484,7 @@
             </a:ln>
             <a:extLst>
               <a:ext uri="{91240B29-F687-4f45-9708-019B960494DF}">
-                <a14:hiddenLine xmlns:a14="http://schemas.microsoft.com/office/drawing/2010/main" xmlns="" w="9525">
+                <a14:hiddenLine xmlns="" xmlns:a14="http://schemas.microsoft.com/office/drawing/2010/main" w="9525">
                   <a:solidFill>
                     <a:srgbClr val="000000"/>
                   </a:solidFill>
@@ -1546,7 +1546,7 @@
             </a:ln>
             <a:extLst>
               <a:ext uri="{91240B29-F687-4f45-9708-019B960494DF}">
-                <a14:hiddenLine xmlns:a14="http://schemas.microsoft.com/office/drawing/2010/main" xmlns="" w="9525">
+                <a14:hiddenLine xmlns="" xmlns:a14="http://schemas.microsoft.com/office/drawing/2010/main" w="9525">
                   <a:solidFill>
                     <a:srgbClr val="000000"/>
                   </a:solidFill>
@@ -1636,7 +1636,7 @@
             </a:ln>
             <a:extLst>
               <a:ext uri="{91240B29-F687-4f45-9708-019B960494DF}">
-                <a14:hiddenLine xmlns:a14="http://schemas.microsoft.com/office/drawing/2010/main" xmlns="" w="9525">
+                <a14:hiddenLine xmlns="" xmlns:a14="http://schemas.microsoft.com/office/drawing/2010/main" w="9525">
                   <a:solidFill>
                     <a:srgbClr val="000000"/>
                   </a:solidFill>
@@ -1726,7 +1726,7 @@
             </a:ln>
             <a:extLst>
               <a:ext uri="{91240B29-F687-4f45-9708-019B960494DF}">
-                <a14:hiddenLine xmlns:a14="http://schemas.microsoft.com/office/drawing/2010/main" xmlns="" w="9525">
+                <a14:hiddenLine xmlns="" xmlns:a14="http://schemas.microsoft.com/office/drawing/2010/main" w="9525">
                   <a:solidFill>
                     <a:srgbClr val="000000"/>
                   </a:solidFill>
@@ -1782,7 +1782,7 @@
             </a:ln>
             <a:extLst>
               <a:ext uri="{91240B29-F687-4f45-9708-019B960494DF}">
-                <a14:hiddenLine xmlns:a14="http://schemas.microsoft.com/office/drawing/2010/main" xmlns="" w="9525">
+                <a14:hiddenLine xmlns="" xmlns:a14="http://schemas.microsoft.com/office/drawing/2010/main" w="9525">
                   <a:solidFill>
                     <a:srgbClr val="000000"/>
                   </a:solidFill>
@@ -1872,7 +1872,7 @@
             </a:ln>
             <a:extLst>
               <a:ext uri="{91240B29-F687-4f45-9708-019B960494DF}">
-                <a14:hiddenLine xmlns:a14="http://schemas.microsoft.com/office/drawing/2010/main" xmlns="" w="9525">
+                <a14:hiddenLine xmlns="" xmlns:a14="http://schemas.microsoft.com/office/drawing/2010/main" w="9525">
                   <a:solidFill>
                     <a:srgbClr val="000000"/>
                   </a:solidFill>
@@ -1928,7 +1928,7 @@
             </a:ln>
             <a:extLst>
               <a:ext uri="{91240B29-F687-4f45-9708-019B960494DF}">
-                <a14:hiddenLine xmlns:a14="http://schemas.microsoft.com/office/drawing/2010/main" xmlns="" w="9525">
+                <a14:hiddenLine xmlns="" xmlns:a14="http://schemas.microsoft.com/office/drawing/2010/main" w="9525">
                   <a:solidFill>
                     <a:srgbClr val="000000"/>
                   </a:solidFill>
@@ -2018,7 +2018,7 @@
             </a:ln>
             <a:extLst>
               <a:ext uri="{91240B29-F687-4f45-9708-019B960494DF}">
-                <a14:hiddenLine xmlns:a14="http://schemas.microsoft.com/office/drawing/2010/main" xmlns="" w="9525">
+                <a14:hiddenLine xmlns="" xmlns:a14="http://schemas.microsoft.com/office/drawing/2010/main" w="9525">
                   <a:solidFill>
                     <a:srgbClr val="000000"/>
                   </a:solidFill>
@@ -2086,7 +2086,7 @@
             </a:ln>
             <a:extLst>
               <a:ext uri="{91240B29-F687-4f45-9708-019B960494DF}">
-                <a14:hiddenLine xmlns:a14="http://schemas.microsoft.com/office/drawing/2010/main" xmlns="" w="9525">
+                <a14:hiddenLine xmlns="" xmlns:a14="http://schemas.microsoft.com/office/drawing/2010/main" w="9525">
                   <a:solidFill>
                     <a:srgbClr val="000000"/>
                   </a:solidFill>
@@ -2176,7 +2176,7 @@
             </a:ln>
             <a:extLst>
               <a:ext uri="{91240B29-F687-4f45-9708-019B960494DF}">
-                <a14:hiddenLine xmlns:a14="http://schemas.microsoft.com/office/drawing/2010/main" xmlns="" w="9525">
+                <a14:hiddenLine xmlns="" xmlns:a14="http://schemas.microsoft.com/office/drawing/2010/main" w="9525">
                   <a:solidFill>
                     <a:srgbClr val="000000"/>
                   </a:solidFill>
@@ -2244,7 +2244,7 @@
             </a:ln>
             <a:extLst>
               <a:ext uri="{91240B29-F687-4f45-9708-019B960494DF}">
-                <a14:hiddenLine xmlns:a14="http://schemas.microsoft.com/office/drawing/2010/main" xmlns="" w="9525">
+                <a14:hiddenLine xmlns="" xmlns:a14="http://schemas.microsoft.com/office/drawing/2010/main" w="9525">
                   <a:solidFill>
                     <a:srgbClr val="000000"/>
                   </a:solidFill>
@@ -2334,7 +2334,7 @@
             </a:ln>
             <a:extLst>
               <a:ext uri="{91240B29-F687-4f45-9708-019B960494DF}">
-                <a14:hiddenLine xmlns:a14="http://schemas.microsoft.com/office/drawing/2010/main" xmlns="" w="9525">
+                <a14:hiddenLine xmlns="" xmlns:a14="http://schemas.microsoft.com/office/drawing/2010/main" w="9525">
                   <a:solidFill>
                     <a:srgbClr val="000000"/>
                   </a:solidFill>
@@ -2368,7 +2368,7 @@
             </a:ln>
             <a:extLst>
               <a:ext uri="{91240B29-F687-4f45-9708-019B960494DF}">
-                <a14:hiddenLine xmlns:a14="http://schemas.microsoft.com/office/drawing/2010/main" xmlns="" w="9525">
+                <a14:hiddenLine xmlns="" xmlns:a14="http://schemas.microsoft.com/office/drawing/2010/main" w="9525">
                   <a:solidFill>
                     <a:srgbClr val="000000"/>
                   </a:solidFill>
@@ -2458,7 +2458,7 @@
             </a:ln>
             <a:extLst>
               <a:ext uri="{91240B29-F687-4f45-9708-019B960494DF}">
-                <a14:hiddenLine xmlns:a14="http://schemas.microsoft.com/office/drawing/2010/main" xmlns="" w="9525">
+                <a14:hiddenLine xmlns="" xmlns:a14="http://schemas.microsoft.com/office/drawing/2010/main" w="9525">
                   <a:solidFill>
                     <a:srgbClr val="000000"/>
                   </a:solidFill>
@@ -2520,7 +2520,7 @@
             </a:ln>
             <a:extLst>
               <a:ext uri="{91240B29-F687-4f45-9708-019B960494DF}">
-                <a14:hiddenLine xmlns:a14="http://schemas.microsoft.com/office/drawing/2010/main" xmlns="" w="9525">
+                <a14:hiddenLine xmlns="" xmlns:a14="http://schemas.microsoft.com/office/drawing/2010/main" w="9525">
                   <a:solidFill>
                     <a:srgbClr val="000000"/>
                   </a:solidFill>
@@ -2582,7 +2582,7 @@
             </a:ln>
             <a:extLst>
               <a:ext uri="{91240B29-F687-4f45-9708-019B960494DF}">
-                <a14:hiddenLine xmlns:a14="http://schemas.microsoft.com/office/drawing/2010/main" xmlns="" w="9525">
+                <a14:hiddenLine xmlns="" xmlns:a14="http://schemas.microsoft.com/office/drawing/2010/main" w="9525">
                   <a:solidFill>
                     <a:srgbClr val="000000"/>
                   </a:solidFill>
@@ -2672,7 +2672,7 @@
             </a:ln>
             <a:extLst>
               <a:ext uri="{91240B29-F687-4f45-9708-019B960494DF}">
-                <a14:hiddenLine xmlns:a14="http://schemas.microsoft.com/office/drawing/2010/main" xmlns="" w="9525">
+                <a14:hiddenLine xmlns="" xmlns:a14="http://schemas.microsoft.com/office/drawing/2010/main" w="9525">
                   <a:solidFill>
                     <a:srgbClr val="000000"/>
                   </a:solidFill>
@@ -2740,7 +2740,7 @@
             </a:ln>
             <a:extLst>
               <a:ext uri="{91240B29-F687-4f45-9708-019B960494DF}">
-                <a14:hiddenLine xmlns:a14="http://schemas.microsoft.com/office/drawing/2010/main" xmlns="" w="9525">
+                <a14:hiddenLine xmlns="" xmlns:a14="http://schemas.microsoft.com/office/drawing/2010/main" w="9525">
                   <a:solidFill>
                     <a:srgbClr val="000000"/>
                   </a:solidFill>
@@ -2802,7 +2802,7 @@
             </a:ln>
             <a:extLst>
               <a:ext uri="{91240B29-F687-4f45-9708-019B960494DF}">
-                <a14:hiddenLine xmlns:a14="http://schemas.microsoft.com/office/drawing/2010/main" xmlns="" w="9525">
+                <a14:hiddenLine xmlns="" xmlns:a14="http://schemas.microsoft.com/office/drawing/2010/main" w="9525">
                   <a:solidFill>
                     <a:srgbClr val="000000"/>
                   </a:solidFill>
@@ -2892,7 +2892,7 @@
             </a:ln>
             <a:extLst>
               <a:ext uri="{91240B29-F687-4f45-9708-019B960494DF}">
-                <a14:hiddenLine xmlns:a14="http://schemas.microsoft.com/office/drawing/2010/main" xmlns="" w="9525">
+                <a14:hiddenLine xmlns="" xmlns:a14="http://schemas.microsoft.com/office/drawing/2010/main" w="9525">
                   <a:solidFill>
                     <a:srgbClr val="000000"/>
                   </a:solidFill>
@@ -2954,7 +2954,7 @@
             </a:ln>
             <a:extLst>
               <a:ext uri="{91240B29-F687-4f45-9708-019B960494DF}">
-                <a14:hiddenLine xmlns:a14="http://schemas.microsoft.com/office/drawing/2010/main" xmlns="" w="9525">
+                <a14:hiddenLine xmlns="" xmlns:a14="http://schemas.microsoft.com/office/drawing/2010/main" w="9525">
                   <a:solidFill>
                     <a:srgbClr val="000000"/>
                   </a:solidFill>
@@ -3044,7 +3044,7 @@
             </a:ln>
             <a:extLst>
               <a:ext uri="{91240B29-F687-4f45-9708-019B960494DF}">
-                <a14:hiddenLine xmlns:a14="http://schemas.microsoft.com/office/drawing/2010/main" xmlns="" w="9525">
+                <a14:hiddenLine xmlns="" xmlns:a14="http://schemas.microsoft.com/office/drawing/2010/main" w="9525">
                   <a:solidFill>
                     <a:srgbClr val="000000"/>
                   </a:solidFill>
@@ -3106,7 +3106,7 @@
             </a:ln>
             <a:extLst>
               <a:ext uri="{91240B29-F687-4f45-9708-019B960494DF}">
-                <a14:hiddenLine xmlns:a14="http://schemas.microsoft.com/office/drawing/2010/main" xmlns="" w="9525">
+                <a14:hiddenLine xmlns="" xmlns:a14="http://schemas.microsoft.com/office/drawing/2010/main" w="9525">
                   <a:solidFill>
                     <a:srgbClr val="000000"/>
                   </a:solidFill>
@@ -3196,7 +3196,7 @@
             </a:ln>
             <a:extLst>
               <a:ext uri="{91240B29-F687-4f45-9708-019B960494DF}">
-                <a14:hiddenLine xmlns:a14="http://schemas.microsoft.com/office/drawing/2010/main" xmlns="" w="9525">
+                <a14:hiddenLine xmlns="" xmlns:a14="http://schemas.microsoft.com/office/drawing/2010/main" w="9525">
                   <a:solidFill>
                     <a:srgbClr val="000000"/>
                   </a:solidFill>
@@ -3230,7 +3230,7 @@
             </a:ln>
             <a:extLst>
               <a:ext uri="{91240B29-F687-4f45-9708-019B960494DF}">
-                <a14:hiddenLine xmlns:a14="http://schemas.microsoft.com/office/drawing/2010/main" xmlns="" w="9525">
+                <a14:hiddenLine xmlns="" xmlns:a14="http://schemas.microsoft.com/office/drawing/2010/main" w="9525">
                   <a:solidFill>
                     <a:srgbClr val="000000"/>
                   </a:solidFill>
@@ -3295,7 +3295,7 @@
             </a:ln>
             <a:extLst>
               <a:ext uri="{91240B29-F687-4f45-9708-019B960494DF}">
-                <a14:hiddenLine xmlns:a14="http://schemas.microsoft.com/office/drawing/2010/main" xmlns="" w="9525">
+                <a14:hiddenLine xmlns="" xmlns:a14="http://schemas.microsoft.com/office/drawing/2010/main" w="9525">
                   <a:solidFill>
                     <a:srgbClr val="000000"/>
                   </a:solidFill>
@@ -3385,7 +3385,7 @@
             </a:ln>
             <a:extLst>
               <a:ext uri="{91240B29-F687-4f45-9708-019B960494DF}">
-                <a14:hiddenLine xmlns:a14="http://schemas.microsoft.com/office/drawing/2010/main" xmlns="" w="9525">
+                <a14:hiddenLine xmlns="" xmlns:a14="http://schemas.microsoft.com/office/drawing/2010/main" w="9525">
                   <a:solidFill>
                     <a:srgbClr val="000000"/>
                   </a:solidFill>
@@ -3447,7 +3447,7 @@
             </a:ln>
             <a:extLst>
               <a:ext uri="{91240B29-F687-4f45-9708-019B960494DF}">
-                <a14:hiddenLine xmlns:a14="http://schemas.microsoft.com/office/drawing/2010/main" xmlns="" w="9525">
+                <a14:hiddenLine xmlns="" xmlns:a14="http://schemas.microsoft.com/office/drawing/2010/main" w="9525">
                   <a:solidFill>
                     <a:srgbClr val="000000"/>
                   </a:solidFill>
@@ -3537,7 +3537,7 @@
             </a:ln>
             <a:extLst>
               <a:ext uri="{91240B29-F687-4f45-9708-019B960494DF}">
-                <a14:hiddenLine xmlns:a14="http://schemas.microsoft.com/office/drawing/2010/main" xmlns="" w="9525">
+                <a14:hiddenLine xmlns="" xmlns:a14="http://schemas.microsoft.com/office/drawing/2010/main" w="9525">
                   <a:solidFill>
                     <a:srgbClr val="000000"/>
                   </a:solidFill>
@@ -3627,7 +3627,7 @@
             </a:ln>
             <a:extLst>
               <a:ext uri="{91240B29-F687-4f45-9708-019B960494DF}">
-                <a14:hiddenLine xmlns:a14="http://schemas.microsoft.com/office/drawing/2010/main" xmlns="" w="9525">
+                <a14:hiddenLine xmlns="" xmlns:a14="http://schemas.microsoft.com/office/drawing/2010/main" w="9525">
                   <a:solidFill>
                     <a:srgbClr val="000000"/>
                   </a:solidFill>
@@ -3692,7 +3692,7 @@
             </a:ln>
             <a:extLst>
               <a:ext uri="{91240B29-F687-4f45-9708-019B960494DF}">
-                <a14:hiddenLine xmlns:a14="http://schemas.microsoft.com/office/drawing/2010/main" xmlns="" w="9525">
+                <a14:hiddenLine xmlns="" xmlns:a14="http://schemas.microsoft.com/office/drawing/2010/main" w="9525">
                   <a:solidFill>
                     <a:srgbClr val="000000"/>
                   </a:solidFill>
@@ -3754,7 +3754,7 @@
             </a:ln>
             <a:extLst>
               <a:ext uri="{91240B29-F687-4f45-9708-019B960494DF}">
-                <a14:hiddenLine xmlns:a14="http://schemas.microsoft.com/office/drawing/2010/main" xmlns="" w="9525">
+                <a14:hiddenLine xmlns="" xmlns:a14="http://schemas.microsoft.com/office/drawing/2010/main" w="9525">
                   <a:solidFill>
                     <a:srgbClr val="000000"/>
                   </a:solidFill>
@@ -3844,7 +3844,7 @@
             </a:ln>
             <a:extLst>
               <a:ext uri="{91240B29-F687-4f45-9708-019B960494DF}">
-                <a14:hiddenLine xmlns:a14="http://schemas.microsoft.com/office/drawing/2010/main" xmlns="" w="9525">
+                <a14:hiddenLine xmlns="" xmlns:a14="http://schemas.microsoft.com/office/drawing/2010/main" w="9525">
                   <a:solidFill>
                     <a:srgbClr val="000000"/>
                   </a:solidFill>
@@ -3934,7 +3934,7 @@
             </a:ln>
             <a:extLst>
               <a:ext uri="{91240B29-F687-4f45-9708-019B960494DF}">
-                <a14:hiddenLine xmlns:a14="http://schemas.microsoft.com/office/drawing/2010/main" xmlns="" w="9525">
+                <a14:hiddenLine xmlns="" xmlns:a14="http://schemas.microsoft.com/office/drawing/2010/main" w="9525">
                   <a:solidFill>
                     <a:srgbClr val="000000"/>
                   </a:solidFill>
@@ -3996,7 +3996,7 @@
             </a:ln>
             <a:extLst>
               <a:ext uri="{91240B29-F687-4f45-9708-019B960494DF}">
-                <a14:hiddenLine xmlns:a14="http://schemas.microsoft.com/office/drawing/2010/main" xmlns="" w="9525">
+                <a14:hiddenLine xmlns="" xmlns:a14="http://schemas.microsoft.com/office/drawing/2010/main" w="9525">
                   <a:solidFill>
                     <a:srgbClr val="000000"/>
                   </a:solidFill>
@@ -4116,7 +4116,7 @@
             </a:ln>
             <a:extLst>
               <a:ext uri="{91240B29-F687-4f45-9708-019B960494DF}">
-                <a14:hiddenLine xmlns:a14="http://schemas.microsoft.com/office/drawing/2010/main" xmlns="" w="9525">
+                <a14:hiddenLine xmlns="" xmlns:a14="http://schemas.microsoft.com/office/drawing/2010/main" w="9525">
                   <a:solidFill>
                     <a:srgbClr val="000000"/>
                   </a:solidFill>
@@ -4184,7 +4184,7 @@
             </a:ln>
             <a:extLst>
               <a:ext uri="{91240B29-F687-4f45-9708-019B960494DF}">
-                <a14:hiddenLine xmlns:a14="http://schemas.microsoft.com/office/drawing/2010/main" xmlns="" w="9525">
+                <a14:hiddenLine xmlns="" xmlns:a14="http://schemas.microsoft.com/office/drawing/2010/main" w="9525">
                   <a:solidFill>
                     <a:srgbClr val="000000"/>
                   </a:solidFill>
@@ -4274,7 +4274,7 @@
             </a:ln>
             <a:extLst>
               <a:ext uri="{91240B29-F687-4f45-9708-019B960494DF}">
-                <a14:hiddenLine xmlns:a14="http://schemas.microsoft.com/office/drawing/2010/main" xmlns="" w="9525">
+                <a14:hiddenLine xmlns="" xmlns:a14="http://schemas.microsoft.com/office/drawing/2010/main" w="9525">
                   <a:solidFill>
                     <a:srgbClr val="000000"/>
                   </a:solidFill>
@@ -4414,7 +4414,7 @@
           <a:p>
             <a:fld id="{7D5207A7-6A00-4516-866C-43D057526ED9}" type="datetimeFigureOut">
               <a:rPr lang="ru-RU" smtClean="0"/>
-              <a:t>02.09.2026</a:t>
+              <a:t>09.09.2026</a:t>
             </a:fld>
             <a:endParaRPr lang="ru-RU"/>
           </a:p>
@@ -4681,7 +4681,7 @@
           <a:p>
             <a:fld id="{7D5207A7-6A00-4516-866C-43D057526ED9}" type="datetimeFigureOut">
               <a:rPr lang="ru-RU" smtClean="0"/>
-              <a:t>02.09.2026</a:t>
+              <a:t>09.09.2026</a:t>
             </a:fld>
             <a:endParaRPr lang="ru-RU"/>
           </a:p>
@@ -4877,7 +4877,7 @@
           <a:p>
             <a:fld id="{7D5207A7-6A00-4516-866C-43D057526ED9}" type="datetimeFigureOut">
               <a:rPr lang="ru-RU" smtClean="0"/>
-              <a:t>02.09.2026</a:t>
+              <a:t>09.09.2026</a:t>
             </a:fld>
             <a:endParaRPr lang="ru-RU"/>
           </a:p>
@@ -5140,7 +5140,7 @@
           <a:p>
             <a:fld id="{7D5207A7-6A00-4516-866C-43D057526ED9}" type="datetimeFigureOut">
               <a:rPr lang="ru-RU" smtClean="0"/>
-              <a:t>02.09.2026</a:t>
+              <a:t>09.09.2026</a:t>
             </a:fld>
             <a:endParaRPr lang="ru-RU"/>
           </a:p>
@@ -5574,7 +5574,7 @@
           <a:p>
             <a:fld id="{7D5207A7-6A00-4516-866C-43D057526ED9}" type="datetimeFigureOut">
               <a:rPr lang="ru-RU" smtClean="0"/>
-              <a:t>02.09.2026</a:t>
+              <a:t>09.09.2026</a:t>
             </a:fld>
             <a:endParaRPr lang="ru-RU"/>
           </a:p>
@@ -6120,7 +6120,7 @@
           <a:p>
             <a:fld id="{7D5207A7-6A00-4516-866C-43D057526ED9}" type="datetimeFigureOut">
               <a:rPr lang="ru-RU" smtClean="0"/>
-              <a:t>02.09.2026</a:t>
+              <a:t>09.09.2026</a:t>
             </a:fld>
             <a:endParaRPr lang="ru-RU"/>
           </a:p>
@@ -6840,7 +6840,7 @@
           <a:p>
             <a:fld id="{7D5207A7-6A00-4516-866C-43D057526ED9}" type="datetimeFigureOut">
               <a:rPr lang="ru-RU" smtClean="0"/>
-              <a:t>02.09.2026</a:t>
+              <a:t>09.09.2026</a:t>
             </a:fld>
             <a:endParaRPr lang="ru-RU"/>
           </a:p>
@@ -7010,7 +7010,7 @@
           <a:p>
             <a:fld id="{7D5207A7-6A00-4516-866C-43D057526ED9}" type="datetimeFigureOut">
               <a:rPr lang="ru-RU" smtClean="0"/>
-              <a:t>02.09.2026</a:t>
+              <a:t>09.09.2026</a:t>
             </a:fld>
             <a:endParaRPr lang="ru-RU"/>
           </a:p>
@@ -7190,7 +7190,7 @@
           <a:p>
             <a:fld id="{7D5207A7-6A00-4516-866C-43D057526ED9}" type="datetimeFigureOut">
               <a:rPr lang="ru-RU" smtClean="0"/>
-              <a:t>02.09.2026</a:t>
+              <a:t>09.09.2026</a:t>
             </a:fld>
             <a:endParaRPr lang="ru-RU"/>
           </a:p>
@@ -7360,7 +7360,7 @@
           <a:p>
             <a:fld id="{7D5207A7-6A00-4516-866C-43D057526ED9}" type="datetimeFigureOut">
               <a:rPr lang="ru-RU" smtClean="0"/>
-              <a:t>02.09.2026</a:t>
+              <a:t>09.09.2026</a:t>
             </a:fld>
             <a:endParaRPr lang="ru-RU"/>
           </a:p>
@@ -7610,7 +7610,7 @@
           <a:p>
             <a:fld id="{7D5207A7-6A00-4516-866C-43D057526ED9}" type="datetimeFigureOut">
               <a:rPr lang="ru-RU" smtClean="0"/>
-              <a:t>02.09.2026</a:t>
+              <a:t>09.09.2026</a:t>
             </a:fld>
             <a:endParaRPr lang="ru-RU"/>
           </a:p>
@@ -7842,7 +7842,7 @@
           <a:p>
             <a:fld id="{7D5207A7-6A00-4516-866C-43D057526ED9}" type="datetimeFigureOut">
               <a:rPr lang="ru-RU" smtClean="0"/>
-              <a:t>02.09.2026</a:t>
+              <a:t>09.09.2026</a:t>
             </a:fld>
             <a:endParaRPr lang="ru-RU"/>
           </a:p>
@@ -8223,7 +8223,7 @@
           <a:p>
             <a:fld id="{7D5207A7-6A00-4516-866C-43D057526ED9}" type="datetimeFigureOut">
               <a:rPr lang="ru-RU" smtClean="0"/>
-              <a:t>02.09.2026</a:t>
+              <a:t>09.09.2026</a:t>
             </a:fld>
             <a:endParaRPr lang="ru-RU"/>
           </a:p>
@@ -8341,7 +8341,7 @@
           <a:p>
             <a:fld id="{7D5207A7-6A00-4516-866C-43D057526ED9}" type="datetimeFigureOut">
               <a:rPr lang="ru-RU" smtClean="0"/>
-              <a:t>02.09.2026</a:t>
+              <a:t>09.09.2026</a:t>
             </a:fld>
             <a:endParaRPr lang="ru-RU"/>
           </a:p>
@@ -8436,7 +8436,7 @@
           <a:p>
             <a:fld id="{7D5207A7-6A00-4516-866C-43D057526ED9}" type="datetimeFigureOut">
               <a:rPr lang="ru-RU" smtClean="0"/>
-              <a:t>02.09.2026</a:t>
+              <a:t>09.09.2026</a:t>
             </a:fld>
             <a:endParaRPr lang="ru-RU"/>
           </a:p>
@@ -8685,7 +8685,7 @@
           <a:p>
             <a:fld id="{7D5207A7-6A00-4516-866C-43D057526ED9}" type="datetimeFigureOut">
               <a:rPr lang="ru-RU" smtClean="0"/>
-              <a:t>02.09.2026</a:t>
+              <a:t>09.09.2026</a:t>
             </a:fld>
             <a:endParaRPr lang="ru-RU"/>
           </a:p>
@@ -8965,7 +8965,7 @@
           <a:p>
             <a:fld id="{7D5207A7-6A00-4516-866C-43D057526ED9}" type="datetimeFigureOut">
               <a:rPr lang="ru-RU" smtClean="0"/>
-              <a:t>02.09.2026</a:t>
+              <a:t>09.09.2026</a:t>
             </a:fld>
             <a:endParaRPr lang="ru-RU"/>
           </a:p>
@@ -9088,7 +9088,7 @@
           <a:noFill/>
           <a:extLst>
             <a:ext uri="{909E8E84-426E-40dd-AFC4-6F175D3DCCD1}">
-              <a14:hiddenFill xmlns:a14="http://schemas.microsoft.com/office/drawing/2010/main" xmlns="">
+              <a14:hiddenFill xmlns="" xmlns:a14="http://schemas.microsoft.com/office/drawing/2010/main">
                 <a:solidFill>
                   <a:srgbClr val="FFFFFF"/>
                 </a:solidFill>
@@ -9162,7 +9162,7 @@
               </a:ln>
               <a:extLst>
                 <a:ext uri="{91240B29-F687-4f45-9708-019B960494DF}">
-                  <a14:hiddenLine xmlns:a14="http://schemas.microsoft.com/office/drawing/2010/main" xmlns="" w="9525">
+                  <a14:hiddenLine xmlns="" xmlns:a14="http://schemas.microsoft.com/office/drawing/2010/main" w="9525">
                     <a:solidFill>
                       <a:srgbClr val="000000"/>
                     </a:solidFill>
@@ -9252,7 +9252,7 @@
               </a:ln>
               <a:extLst>
                 <a:ext uri="{91240B29-F687-4f45-9708-019B960494DF}">
-                  <a14:hiddenLine xmlns:a14="http://schemas.microsoft.com/office/drawing/2010/main" xmlns="" w="9525">
+                  <a14:hiddenLine xmlns="" xmlns:a14="http://schemas.microsoft.com/office/drawing/2010/main" w="9525">
                     <a:solidFill>
                       <a:srgbClr val="000000"/>
                     </a:solidFill>
@@ -9342,7 +9342,7 @@
               </a:ln>
               <a:extLst>
                 <a:ext uri="{91240B29-F687-4f45-9708-019B960494DF}">
-                  <a14:hiddenLine xmlns:a14="http://schemas.microsoft.com/office/drawing/2010/main" xmlns="" w="9525">
+                  <a14:hiddenLine xmlns="" xmlns:a14="http://schemas.microsoft.com/office/drawing/2010/main" w="9525">
                     <a:solidFill>
                       <a:srgbClr val="000000"/>
                     </a:solidFill>
@@ -9404,7 +9404,7 @@
               </a:ln>
               <a:extLst>
                 <a:ext uri="{91240B29-F687-4f45-9708-019B960494DF}">
-                  <a14:hiddenLine xmlns:a14="http://schemas.microsoft.com/office/drawing/2010/main" xmlns="" w="9525">
+                  <a14:hiddenLine xmlns="" xmlns:a14="http://schemas.microsoft.com/office/drawing/2010/main" w="9525">
                     <a:solidFill>
                       <a:srgbClr val="000000"/>
                     </a:solidFill>
@@ -9494,7 +9494,7 @@
               </a:ln>
               <a:extLst>
                 <a:ext uri="{91240B29-F687-4f45-9708-019B960494DF}">
-                  <a14:hiddenLine xmlns:a14="http://schemas.microsoft.com/office/drawing/2010/main" xmlns="" w="9525">
+                  <a14:hiddenLine xmlns="" xmlns:a14="http://schemas.microsoft.com/office/drawing/2010/main" w="9525">
                     <a:solidFill>
                       <a:srgbClr val="000000"/>
                     </a:solidFill>
@@ -9556,7 +9556,7 @@
               </a:ln>
               <a:extLst>
                 <a:ext uri="{91240B29-F687-4f45-9708-019B960494DF}">
-                  <a14:hiddenLine xmlns:a14="http://schemas.microsoft.com/office/drawing/2010/main" xmlns="" w="9525">
+                  <a14:hiddenLine xmlns="" xmlns:a14="http://schemas.microsoft.com/office/drawing/2010/main" w="9525">
                     <a:solidFill>
                       <a:srgbClr val="000000"/>
                     </a:solidFill>
@@ -9618,7 +9618,7 @@
               </a:ln>
               <a:extLst>
                 <a:ext uri="{91240B29-F687-4f45-9708-019B960494DF}">
-                  <a14:hiddenLine xmlns:a14="http://schemas.microsoft.com/office/drawing/2010/main" xmlns="" w="9525">
+                  <a14:hiddenLine xmlns="" xmlns:a14="http://schemas.microsoft.com/office/drawing/2010/main" w="9525">
                     <a:solidFill>
                       <a:srgbClr val="000000"/>
                     </a:solidFill>
@@ -9708,7 +9708,7 @@
               </a:ln>
               <a:extLst>
                 <a:ext uri="{91240B29-F687-4f45-9708-019B960494DF}">
-                  <a14:hiddenLine xmlns:a14="http://schemas.microsoft.com/office/drawing/2010/main" xmlns="" w="9525">
+                  <a14:hiddenLine xmlns="" xmlns:a14="http://schemas.microsoft.com/office/drawing/2010/main" w="9525">
                     <a:solidFill>
                       <a:srgbClr val="000000"/>
                     </a:solidFill>
@@ -9798,7 +9798,7 @@
               </a:ln>
               <a:extLst>
                 <a:ext uri="{91240B29-F687-4f45-9708-019B960494DF}">
-                  <a14:hiddenLine xmlns:a14="http://schemas.microsoft.com/office/drawing/2010/main" xmlns="" w="9525">
+                  <a14:hiddenLine xmlns="" xmlns:a14="http://schemas.microsoft.com/office/drawing/2010/main" w="9525">
                     <a:solidFill>
                       <a:srgbClr val="000000"/>
                     </a:solidFill>
@@ -9860,7 +9860,7 @@
               </a:ln>
               <a:extLst>
                 <a:ext uri="{91240B29-F687-4f45-9708-019B960494DF}">
-                  <a14:hiddenLine xmlns:a14="http://schemas.microsoft.com/office/drawing/2010/main" xmlns="" w="9525">
+                  <a14:hiddenLine xmlns="" xmlns:a14="http://schemas.microsoft.com/office/drawing/2010/main" w="9525">
                     <a:solidFill>
                       <a:srgbClr val="000000"/>
                     </a:solidFill>
@@ -9970,7 +9970,7 @@
               </a:ln>
               <a:extLst>
                 <a:ext uri="{91240B29-F687-4f45-9708-019B960494DF}">
-                  <a14:hiddenLine xmlns:a14="http://schemas.microsoft.com/office/drawing/2010/main" xmlns="" w="9525">
+                  <a14:hiddenLine xmlns="" xmlns:a14="http://schemas.microsoft.com/office/drawing/2010/main" w="9525">
                     <a:solidFill>
                       <a:srgbClr val="000000"/>
                     </a:solidFill>
@@ -10054,7 +10054,7 @@
               </a:ln>
               <a:extLst>
                 <a:ext uri="{91240B29-F687-4f45-9708-019B960494DF}">
-                  <a14:hiddenLine xmlns:a14="http://schemas.microsoft.com/office/drawing/2010/main" xmlns="" w="9525">
+                  <a14:hiddenLine xmlns="" xmlns:a14="http://schemas.microsoft.com/office/drawing/2010/main" w="9525">
                     <a:solidFill>
                       <a:srgbClr val="000000"/>
                     </a:solidFill>
@@ -10116,7 +10116,7 @@
               </a:ln>
               <a:extLst>
                 <a:ext uri="{91240B29-F687-4f45-9708-019B960494DF}">
-                  <a14:hiddenLine xmlns:a14="http://schemas.microsoft.com/office/drawing/2010/main" xmlns="" w="9525">
+                  <a14:hiddenLine xmlns="" xmlns:a14="http://schemas.microsoft.com/office/drawing/2010/main" w="9525">
                     <a:solidFill>
                       <a:srgbClr val="000000"/>
                     </a:solidFill>
@@ -10178,7 +10178,7 @@
               </a:ln>
               <a:extLst>
                 <a:ext uri="{91240B29-F687-4f45-9708-019B960494DF}">
-                  <a14:hiddenLine xmlns:a14="http://schemas.microsoft.com/office/drawing/2010/main" xmlns="" w="9525">
+                  <a14:hiddenLine xmlns="" xmlns:a14="http://schemas.microsoft.com/office/drawing/2010/main" w="9525">
                     <a:solidFill>
                       <a:srgbClr val="000000"/>
                     </a:solidFill>
@@ -10268,7 +10268,7 @@
               </a:ln>
               <a:extLst>
                 <a:ext uri="{91240B29-F687-4f45-9708-019B960494DF}">
-                  <a14:hiddenLine xmlns:a14="http://schemas.microsoft.com/office/drawing/2010/main" xmlns="" w="9525">
+                  <a14:hiddenLine xmlns="" xmlns:a14="http://schemas.microsoft.com/office/drawing/2010/main" w="9525">
                     <a:solidFill>
                       <a:srgbClr val="000000"/>
                     </a:solidFill>
@@ -10302,7 +10302,7 @@
               </a:ln>
               <a:extLst>
                 <a:ext uri="{91240B29-F687-4f45-9708-019B960494DF}">
-                  <a14:hiddenLine xmlns:a14="http://schemas.microsoft.com/office/drawing/2010/main" xmlns="" w="9525">
+                  <a14:hiddenLine xmlns="" xmlns:a14="http://schemas.microsoft.com/office/drawing/2010/main" w="9525">
                     <a:solidFill>
                       <a:srgbClr val="000000"/>
                     </a:solidFill>
@@ -10367,7 +10367,7 @@
               </a:ln>
               <a:extLst>
                 <a:ext uri="{91240B29-F687-4f45-9708-019B960494DF}">
-                  <a14:hiddenLine xmlns:a14="http://schemas.microsoft.com/office/drawing/2010/main" xmlns="" w="9525">
+                  <a14:hiddenLine xmlns="" xmlns:a14="http://schemas.microsoft.com/office/drawing/2010/main" w="9525">
                     <a:solidFill>
                       <a:srgbClr val="000000"/>
                     </a:solidFill>
@@ -10457,7 +10457,7 @@
               </a:ln>
               <a:extLst>
                 <a:ext uri="{91240B29-F687-4f45-9708-019B960494DF}">
-                  <a14:hiddenLine xmlns:a14="http://schemas.microsoft.com/office/drawing/2010/main" xmlns="" w="9525">
+                  <a14:hiddenLine xmlns="" xmlns:a14="http://schemas.microsoft.com/office/drawing/2010/main" w="9525">
                     <a:solidFill>
                       <a:srgbClr val="000000"/>
                     </a:solidFill>
@@ -10519,7 +10519,7 @@
               </a:ln>
               <a:extLst>
                 <a:ext uri="{91240B29-F687-4f45-9708-019B960494DF}">
-                  <a14:hiddenLine xmlns:a14="http://schemas.microsoft.com/office/drawing/2010/main" xmlns="" w="9525">
+                  <a14:hiddenLine xmlns="" xmlns:a14="http://schemas.microsoft.com/office/drawing/2010/main" w="9525">
                     <a:solidFill>
                       <a:srgbClr val="000000"/>
                     </a:solidFill>
@@ -10609,7 +10609,7 @@
               </a:ln>
               <a:extLst>
                 <a:ext uri="{91240B29-F687-4f45-9708-019B960494DF}">
-                  <a14:hiddenLine xmlns:a14="http://schemas.microsoft.com/office/drawing/2010/main" xmlns="" w="9525">
+                  <a14:hiddenLine xmlns="" xmlns:a14="http://schemas.microsoft.com/office/drawing/2010/main" w="9525">
                     <a:solidFill>
                       <a:srgbClr val="000000"/>
                     </a:solidFill>
@@ -10674,7 +10674,7 @@
               </a:ln>
               <a:extLst>
                 <a:ext uri="{91240B29-F687-4f45-9708-019B960494DF}">
-                  <a14:hiddenLine xmlns:a14="http://schemas.microsoft.com/office/drawing/2010/main" xmlns="" w="9525">
+                  <a14:hiddenLine xmlns="" xmlns:a14="http://schemas.microsoft.com/office/drawing/2010/main" w="9525">
                     <a:solidFill>
                       <a:srgbClr val="000000"/>
                     </a:solidFill>
@@ -10736,7 +10736,7 @@
               </a:ln>
               <a:extLst>
                 <a:ext uri="{91240B29-F687-4f45-9708-019B960494DF}">
-                  <a14:hiddenLine xmlns:a14="http://schemas.microsoft.com/office/drawing/2010/main" xmlns="" w="9525">
+                  <a14:hiddenLine xmlns="" xmlns:a14="http://schemas.microsoft.com/office/drawing/2010/main" w="9525">
                     <a:solidFill>
                       <a:srgbClr val="000000"/>
                     </a:solidFill>
@@ -10826,7 +10826,7 @@
               </a:ln>
               <a:extLst>
                 <a:ext uri="{91240B29-F687-4f45-9708-019B960494DF}">
-                  <a14:hiddenLine xmlns:a14="http://schemas.microsoft.com/office/drawing/2010/main" xmlns="" w="9525">
+                  <a14:hiddenLine xmlns="" xmlns:a14="http://schemas.microsoft.com/office/drawing/2010/main" w="9525">
                     <a:solidFill>
                       <a:srgbClr val="000000"/>
                     </a:solidFill>
@@ -10916,7 +10916,7 @@
               </a:ln>
               <a:extLst>
                 <a:ext uri="{91240B29-F687-4f45-9708-019B960494DF}">
-                  <a14:hiddenLine xmlns:a14="http://schemas.microsoft.com/office/drawing/2010/main" xmlns="" w="9525">
+                  <a14:hiddenLine xmlns="" xmlns:a14="http://schemas.microsoft.com/office/drawing/2010/main" w="9525">
                     <a:solidFill>
                       <a:srgbClr val="000000"/>
                     </a:solidFill>
@@ -10981,7 +10981,7 @@
               </a:ln>
               <a:extLst>
                 <a:ext uri="{91240B29-F687-4f45-9708-019B960494DF}">
-                  <a14:hiddenLine xmlns:a14="http://schemas.microsoft.com/office/drawing/2010/main" xmlns="" w="9525">
+                  <a14:hiddenLine xmlns="" xmlns:a14="http://schemas.microsoft.com/office/drawing/2010/main" w="9525">
                     <a:solidFill>
                       <a:srgbClr val="000000"/>
                     </a:solidFill>
@@ -11101,7 +11101,7 @@
               </a:ln>
               <a:extLst>
                 <a:ext uri="{91240B29-F687-4f45-9708-019B960494DF}">
-                  <a14:hiddenLine xmlns:a14="http://schemas.microsoft.com/office/drawing/2010/main" xmlns="" w="9525">
+                  <a14:hiddenLine xmlns="" xmlns:a14="http://schemas.microsoft.com/office/drawing/2010/main" w="9525">
                     <a:solidFill>
                       <a:srgbClr val="000000"/>
                     </a:solidFill>
@@ -11182,7 +11182,7 @@
               </a:ln>
               <a:extLst>
                 <a:ext uri="{91240B29-F687-4f45-9708-019B960494DF}">
-                  <a14:hiddenLine xmlns:a14="http://schemas.microsoft.com/office/drawing/2010/main" xmlns="" w="9525">
+                  <a14:hiddenLine xmlns="" xmlns:a14="http://schemas.microsoft.com/office/drawing/2010/main" w="9525">
                     <a:solidFill>
                       <a:srgbClr val="000000"/>
                     </a:solidFill>
@@ -11297,7 +11297,7 @@
               </a:ln>
               <a:extLst>
                 <a:ext uri="{91240B29-F687-4f45-9708-019B960494DF}">
-                  <a14:hiddenLine xmlns:a14="http://schemas.microsoft.com/office/drawing/2010/main" xmlns="" w="9525">
+                  <a14:hiddenLine xmlns="" xmlns:a14="http://schemas.microsoft.com/office/drawing/2010/main" w="9525">
                     <a:solidFill>
                       <a:srgbClr val="000000"/>
                     </a:solidFill>
@@ -11387,7 +11387,7 @@
               </a:ln>
               <a:extLst>
                 <a:ext uri="{91240B29-F687-4f45-9708-019B960494DF}">
-                  <a14:hiddenLine xmlns:a14="http://schemas.microsoft.com/office/drawing/2010/main" xmlns="" w="9525">
+                  <a14:hiddenLine xmlns="" xmlns:a14="http://schemas.microsoft.com/office/drawing/2010/main" w="9525">
                     <a:solidFill>
                       <a:srgbClr val="000000"/>
                     </a:solidFill>
@@ -11452,7 +11452,7 @@
               </a:ln>
               <a:extLst>
                 <a:ext uri="{91240B29-F687-4f45-9708-019B960494DF}">
-                  <a14:hiddenLine xmlns:a14="http://schemas.microsoft.com/office/drawing/2010/main" xmlns="" w="9525">
+                  <a14:hiddenLine xmlns="" xmlns:a14="http://schemas.microsoft.com/office/drawing/2010/main" w="9525">
                     <a:solidFill>
                       <a:srgbClr val="000000"/>
                     </a:solidFill>
@@ -11542,7 +11542,7 @@
               </a:ln>
               <a:extLst>
                 <a:ext uri="{91240B29-F687-4f45-9708-019B960494DF}">
-                  <a14:hiddenLine xmlns:a14="http://schemas.microsoft.com/office/drawing/2010/main" xmlns="" w="9525">
+                  <a14:hiddenLine xmlns="" xmlns:a14="http://schemas.microsoft.com/office/drawing/2010/main" w="9525">
                     <a:solidFill>
                       <a:srgbClr val="000000"/>
                     </a:solidFill>
@@ -11610,7 +11610,7 @@
               </a:ln>
               <a:extLst>
                 <a:ext uri="{91240B29-F687-4f45-9708-019B960494DF}">
-                  <a14:hiddenLine xmlns:a14="http://schemas.microsoft.com/office/drawing/2010/main" xmlns="" w="9525">
+                  <a14:hiddenLine xmlns="" xmlns:a14="http://schemas.microsoft.com/office/drawing/2010/main" w="9525">
                     <a:solidFill>
                       <a:srgbClr val="000000"/>
                     </a:solidFill>
@@ -11700,7 +11700,7 @@
               </a:ln>
               <a:extLst>
                 <a:ext uri="{91240B29-F687-4f45-9708-019B960494DF}">
-                  <a14:hiddenLine xmlns:a14="http://schemas.microsoft.com/office/drawing/2010/main" xmlns="" w="9525">
+                  <a14:hiddenLine xmlns="" xmlns:a14="http://schemas.microsoft.com/office/drawing/2010/main" w="9525">
                     <a:solidFill>
                       <a:srgbClr val="000000"/>
                     </a:solidFill>
@@ -11768,7 +11768,7 @@
               </a:ln>
               <a:extLst>
                 <a:ext uri="{91240B29-F687-4f45-9708-019B960494DF}">
-                  <a14:hiddenLine xmlns:a14="http://schemas.microsoft.com/office/drawing/2010/main" xmlns="" w="9525">
+                  <a14:hiddenLine xmlns="" xmlns:a14="http://schemas.microsoft.com/office/drawing/2010/main" w="9525">
                     <a:solidFill>
                       <a:srgbClr val="000000"/>
                     </a:solidFill>
@@ -11858,7 +11858,7 @@
               </a:ln>
               <a:extLst>
                 <a:ext uri="{91240B29-F687-4f45-9708-019B960494DF}">
-                  <a14:hiddenLine xmlns:a14="http://schemas.microsoft.com/office/drawing/2010/main" xmlns="" w="9525">
+                  <a14:hiddenLine xmlns="" xmlns:a14="http://schemas.microsoft.com/office/drawing/2010/main" w="9525">
                     <a:solidFill>
                       <a:srgbClr val="000000"/>
                     </a:solidFill>
@@ -11892,7 +11892,7 @@
               </a:ln>
               <a:extLst>
                 <a:ext uri="{91240B29-F687-4f45-9708-019B960494DF}">
-                  <a14:hiddenLine xmlns:a14="http://schemas.microsoft.com/office/drawing/2010/main" xmlns="" w="9525">
+                  <a14:hiddenLine xmlns="" xmlns:a14="http://schemas.microsoft.com/office/drawing/2010/main" w="9525">
                     <a:solidFill>
                       <a:srgbClr val="000000"/>
                     </a:solidFill>
@@ -12032,7 +12032,7 @@
           <a:p>
             <a:fld id="{7D5207A7-6A00-4516-866C-43D057526ED9}" type="datetimeFigureOut">
               <a:rPr lang="ru-RU" smtClean="0"/>
-              <a:t>02.09.2026</a:t>
+              <a:t>09.09.2026</a:t>
             </a:fld>
             <a:endParaRPr lang="ru-RU"/>
           </a:p>
@@ -13232,7 +13232,19 @@
           <a:p>
             <a:r>
               <a:rPr lang="en-US" dirty="0" smtClean="0"/>
-              <a:t>Payload: 45-1500 </a:t>
+              <a:t>Payload: </a:t>
+            </a:r>
+            <a:r>
+              <a:rPr lang="en-US" dirty="0" smtClean="0"/>
+              <a:t>4</a:t>
+            </a:r>
+            <a:r>
+              <a:rPr lang="ru-RU" smtClean="0"/>
+              <a:t>6</a:t>
+            </a:r>
+            <a:r>
+              <a:rPr lang="en-US" smtClean="0"/>
+              <a:t>-1500 </a:t>
             </a:r>
             <a:r>
               <a:rPr lang="ru-RU" dirty="0" smtClean="0"/>

</xml_diff>